<commit_message>
Add HistoricalKnowledgeDatabase structure and scripts for database management
</commit_message>
<xml_diff>
--- a/Do An/slide-bao-cao-proposal.pptx
+++ b/Do An/slide-bao-cao-proposal.pptx
@@ -3844,7 +3844,7 @@
                 <a:ea typeface="Arial"/>
                 <a:cs typeface="Arial"/>
               </a:rPr>
-              <a:t>Triển khai hệ thống CSDL đồ thị tri thức và thiết kế pipeline trích xuất mạng lưới thực thể lịch sử 5W1H bằng LLM</a:t>
+              <a:t>Khung tích hợp CSDL lai và Pipeline LLM trong mô hình hóa tri thức lịch sử Việt Nam theo phương pháp 5W1H</a:t>
             </a:r>
           </a:p>
         </p:txBody>
@@ -3878,7 +3878,7 @@
                 <a:ea typeface="Arial"/>
                 <a:cs typeface="Arial"/>
               </a:rPr>
-              <a:t>Implementing a Knowledge Graph Database System and Designing an LLM Pipeline to Extract a 5W1H Network of Historical Entities</a:t>
+              <a:t>An Integrated Framework Combining Hybrid Databases and LLM Pipelines for 5W1H Vietnamese Historical Knowledge Modeling</a:t>
             </a:r>
           </a:p>
         </p:txBody>

</xml_diff>